<commit_message>
Gebruik DPIA in plaats van PIA.
Closes #1004.
</commit_message>
<xml_diff>
--- a/Content/Images/relaties-tussen-producten.pptx
+++ b/Content/Images/relaties-tussen-producten.pptx
@@ -232,7 +232,7 @@
           <a:p>
             <a:fld id="{350B2457-A054-7D40-BA7B-21B0D0BCC8B3}" type="datetimeFigureOut">
               <a:rPr lang="nl-NL" smtClean="0"/>
-              <a:t>28-02-2025</a:t>
+              <a:t>24-03-2025</a:t>
             </a:fld>
             <a:endParaRPr lang="nl-NL"/>
           </a:p>
@@ -373,7 +373,7 @@
             <a:fld id="{B7EEF894-AF89-4A15-B12A-DB6EE2F8B7F6}" type="datetimeFigureOut">
               <a:rPr lang="nl-NL" smtClean="0"/>
               <a:pPr/>
-              <a:t>28-02-2025</a:t>
+              <a:t>24-03-2025</a:t>
             </a:fld>
             <a:endParaRPr lang="nl-NL"/>
           </a:p>
@@ -3450,7 +3450,7 @@
                   <a:schemeClr val="tx1"/>
                 </a:solidFill>
               </a:rPr>
-              <a:t>PIA</a:t>
+              <a:t>DPIA</a:t>
             </a:r>
           </a:p>
         </p:txBody>
@@ -4518,7 +4518,15 @@
           <a:p>
             <a:r>
               <a:rPr lang="nl-NL" sz="1100" dirty="0"/>
-              <a:t>PIA	privacy impact analyse</a:t>
+              <a:t>DPIA	data </a:t>
+            </a:r>
+            <a:r>
+              <a:rPr lang="nl-NL" sz="1100" dirty="0" err="1"/>
+              <a:t>protection</a:t>
+            </a:r>
+            <a:r>
+              <a:rPr lang="nl-NL" sz="1100" dirty="0"/>
+              <a:t> impact analyse</a:t>
             </a:r>
           </a:p>
           <a:p>
@@ -5630,6 +5638,11 @@
 
 <file path=customXml/item1.xml><?xml version="1.0" encoding="utf-8"?>
 <?mso-contentType ?>
+<SharedContentType xmlns="Microsoft.SharePoint.Taxonomy.ContentTypeSync" SourceId="a104d5ce-f540-4606-a78d-e5febbb9402b" ContentTypeId="0x010100CA9CDBB764D01E419D82B5B2D492A06E" PreviousValue="false"/>
+</file>
+
+<file path=customXml/item2.xml><?xml version="1.0" encoding="utf-8"?>
+<?mso-contentType ?>
 <FormTemplates xmlns="http://schemas.microsoft.com/sharepoint/v3/contenttype/forms">
   <Display>DocumentLibraryForm</Display>
   <Edit>DocumentLibraryForm</Edit>
@@ -5637,18 +5650,7 @@
 </FormTemplates>
 </file>
 
-<file path=customXml/item2.xml><?xml version="1.0" encoding="utf-8"?>
-<?mso-contentType ?>
-<SharedContentType xmlns="Microsoft.SharePoint.Taxonomy.ContentTypeSync" SourceId="a104d5ce-f540-4606-a78d-e5febbb9402b" ContentTypeId="0x010100CA9CDBB764D01E419D82B5B2D492A06E" PreviousValue="false"/>
-</file>
-
 <file path=customXml/item3.xml><?xml version="1.0" encoding="utf-8"?>
-<p:properties xmlns:p="http://schemas.microsoft.com/office/2006/metadata/properties" xmlns:xsi="http://www.w3.org/2001/XMLSchema-instance" xmlns:pc="http://schemas.microsoft.com/office/infopath/2007/PartnerControls">
-  <documentManagement/>
-</p:properties>
-</file>
-
-<file path=customXml/item4.xml><?xml version="1.0" encoding="utf-8"?>
 <ct:contentTypeSchema xmlns:ct="http://schemas.microsoft.com/office/2006/metadata/contentType" xmlns:ma="http://schemas.microsoft.com/office/2006/metadata/properties/metaAttributes" ct:_="" ma:_="" ma:contentTypeName="ICTU Blanco Document" ma:contentTypeID="0x010100CA9CDBB764D01E419D82B5B2D492A06E00E64732FD58622849ADF98223EDB743FB" ma:contentTypeVersion="1" ma:contentTypeDescription="Een nieuw document maken." ma:contentTypeScope="" ma:versionID="28f69a9cb16ef1d87fe474606945a2f9">
   <xsd:schema xmlns:xsd="http://www.w3.org/2001/XMLSchema" xmlns:xs="http://www.w3.org/2001/XMLSchema" xmlns:p="http://schemas.microsoft.com/office/2006/metadata/properties" targetNamespace="http://schemas.microsoft.com/office/2006/metadata/properties" ma:root="true" ma:fieldsID="fe1b79ded2d1c66a268d2bc825768432">
     <xsd:element name="properties">
@@ -5762,7 +5764,21 @@
 </ct:contentTypeSchema>
 </file>
 
+<file path=customXml/item4.xml><?xml version="1.0" encoding="utf-8"?>
+<p:properties xmlns:p="http://schemas.microsoft.com/office/2006/metadata/properties" xmlns:xsi="http://www.w3.org/2001/XMLSchema-instance" xmlns:pc="http://schemas.microsoft.com/office/infopath/2007/PartnerControls">
+  <documentManagement/>
+</p:properties>
+</file>
+
 <file path=customXml/itemProps1.xml><?xml version="1.0" encoding="utf-8"?>
+<ds:datastoreItem xmlns:ds="http://schemas.openxmlformats.org/officeDocument/2006/customXml" ds:itemID="{6DB5B419-F5CF-48E9-BE51-6DA9FADDD3D2}">
+  <ds:schemaRefs>
+    <ds:schemaRef ds:uri="Microsoft.SharePoint.Taxonomy.ContentTypeSync"/>
+  </ds:schemaRefs>
+</ds:datastoreItem>
+</file>
+
+<file path=customXml/itemProps2.xml><?xml version="1.0" encoding="utf-8"?>
 <ds:datastoreItem xmlns:ds="http://schemas.openxmlformats.org/officeDocument/2006/customXml" ds:itemID="{C6E14BCB-FF18-43C2-9B39-2D1FBFF2F7E2}">
   <ds:schemaRefs>
     <ds:schemaRef ds:uri="http://schemas.microsoft.com/sharepoint/v3/contenttype/forms"/>
@@ -5770,30 +5786,7 @@
 </ds:datastoreItem>
 </file>
 
-<file path=customXml/itemProps2.xml><?xml version="1.0" encoding="utf-8"?>
-<ds:datastoreItem xmlns:ds="http://schemas.openxmlformats.org/officeDocument/2006/customXml" ds:itemID="{6DB5B419-F5CF-48E9-BE51-6DA9FADDD3D2}">
-  <ds:schemaRefs>
-    <ds:schemaRef ds:uri="Microsoft.SharePoint.Taxonomy.ContentTypeSync"/>
-  </ds:schemaRefs>
-</ds:datastoreItem>
-</file>
-
 <file path=customXml/itemProps3.xml><?xml version="1.0" encoding="utf-8"?>
-<ds:datastoreItem xmlns:ds="http://schemas.openxmlformats.org/officeDocument/2006/customXml" ds:itemID="{0F77E14F-9640-4513-8E7C-CB18D1FB76F5}">
-  <ds:schemaRefs>
-    <ds:schemaRef ds:uri="http://schemas.openxmlformats.org/package/2006/metadata/core-properties"/>
-    <ds:schemaRef ds:uri="http://purl.org/dc/dcmitype/"/>
-    <ds:schemaRef ds:uri="http://purl.org/dc/elements/1.1/"/>
-    <ds:schemaRef ds:uri="http://schemas.microsoft.com/office/2006/documentManagement/types"/>
-    <ds:schemaRef ds:uri="http://purl.org/dc/terms/"/>
-    <ds:schemaRef ds:uri="http://schemas.microsoft.com/office/infopath/2007/PartnerControls"/>
-    <ds:schemaRef ds:uri="http://schemas.microsoft.com/office/2006/metadata/properties"/>
-    <ds:schemaRef ds:uri="http://www.w3.org/XML/1998/namespace"/>
-  </ds:schemaRefs>
-</ds:datastoreItem>
-</file>
-
-<file path=customXml/itemProps4.xml><?xml version="1.0" encoding="utf-8"?>
 <ds:datastoreItem xmlns:ds="http://schemas.openxmlformats.org/officeDocument/2006/customXml" ds:itemID="{4DB5BCB5-1715-4DB7-B20A-25FB39179062}">
   <ds:schemaRefs>
     <ds:schemaRef ds:uri="http://schemas.microsoft.com/office/2006/metadata/contentType"/>
@@ -5807,4 +5800,19 @@
     <ds:schemaRef ds:uri="http://schemas.microsoft.com/office/infopath/2007/PartnerControls"/>
   </ds:schemaRefs>
 </ds:datastoreItem>
+</file>
+
+<file path=customXml/itemProps4.xml><?xml version="1.0" encoding="utf-8"?>
+<ds:datastoreItem xmlns:ds="http://schemas.openxmlformats.org/officeDocument/2006/customXml" ds:itemID="{0F77E14F-9640-4513-8E7C-CB18D1FB76F5}">
+  <ds:schemaRefs>
+    <ds:schemaRef ds:uri="http://schemas.openxmlformats.org/package/2006/metadata/core-properties"/>
+    <ds:schemaRef ds:uri="http://purl.org/dc/dcmitype/"/>
+    <ds:schemaRef ds:uri="http://purl.org/dc/elements/1.1/"/>
+    <ds:schemaRef ds:uri="http://schemas.microsoft.com/office/2006/documentManagement/types"/>
+    <ds:schemaRef ds:uri="http://purl.org/dc/terms/"/>
+    <ds:schemaRef ds:uri="http://schemas.microsoft.com/office/infopath/2007/PartnerControls"/>
+    <ds:schemaRef ds:uri="http://schemas.microsoft.com/office/2006/metadata/properties"/>
+    <ds:schemaRef ds:uri="http://www.w3.org/XML/1998/namespace"/>
+  </ds:schemaRefs>
+</ds:datastoreItem>
 </file>
</xml_diff>